<commit_message>
Section 3: reveal MCQ answers on click in the Arabic PowerPoint
add_answer_animations.py draws a green highlight on each correct option of the
three question slides and fades it in on click, one question per click.

Co-Authored-By: Claude Opus 5.5 (1M context) <noreply@anthropic.com>
Claude-Session: https://claude.ai/code/session_01VXJyxt6aiRyH9qxAXSmm3f
</commit_message>
<xml_diff>
--- a/سكشن 3 — ثبات الاستبيان.pptx
+++ b/سكشن 3 — ثبات الاستبيان.pptx
@@ -13855,11 +13855,371 @@
           </a:p>
         </p:txBody>
       </p:sp>
+      <p:sp>
+        <p:nvSpPr>
+          <p:cNvPr id="62" name="Answer 62"/>
+          <p:cNvSpPr/>
+          <p:nvPr/>
+        </p:nvSpPr>
+        <p:spPr>
+          <a:xfrm>
+            <a:off x="3858498" y="2291717"/>
+            <a:ext cx="996553" cy="461010"/>
+          </a:xfrm>
+          <a:prstGeom prst="roundRect">
+            <a:avLst>
+              <a:gd name="adj" fmla="val 50000"/>
+            </a:avLst>
+          </a:prstGeom>
+          <a:solidFill>
+            <a:srgbClr val="2E8B57">
+              <a:alpha val="22000"/>
+            </a:srgbClr>
+          </a:solidFill>
+          <a:ln w="38100">
+            <a:solidFill>
+              <a:srgbClr val="2E8B57"/>
+            </a:solidFill>
+          </a:ln>
+        </p:spPr>
+      </p:sp>
+      <p:sp>
+        <p:nvSpPr>
+          <p:cNvPr id="63" name="Answer 63"/>
+          <p:cNvSpPr/>
+          <p:nvPr/>
+        </p:nvSpPr>
+        <p:spPr>
+          <a:xfrm>
+            <a:off x="1894046" y="3279775"/>
+            <a:ext cx="2212419" cy="461010"/>
+          </a:xfrm>
+          <a:prstGeom prst="roundRect">
+            <a:avLst>
+              <a:gd name="adj" fmla="val 50000"/>
+            </a:avLst>
+          </a:prstGeom>
+          <a:solidFill>
+            <a:srgbClr val="2E8B57">
+              <a:alpha val="22000"/>
+            </a:srgbClr>
+          </a:solidFill>
+          <a:ln w="38100">
+            <a:solidFill>
+              <a:srgbClr val="2E8B57"/>
+            </a:solidFill>
+          </a:ln>
+        </p:spPr>
+      </p:sp>
+      <p:sp>
+        <p:nvSpPr>
+          <p:cNvPr id="64" name="Answer 64"/>
+          <p:cNvSpPr/>
+          <p:nvPr/>
+        </p:nvSpPr>
+        <p:spPr>
+          <a:xfrm>
+            <a:off x="1656477" y="4267839"/>
+            <a:ext cx="846852" cy="461010"/>
+          </a:xfrm>
+          <a:prstGeom prst="roundRect">
+            <a:avLst>
+              <a:gd name="adj" fmla="val 50000"/>
+            </a:avLst>
+          </a:prstGeom>
+          <a:solidFill>
+            <a:srgbClr val="2E8B57">
+              <a:alpha val="22000"/>
+            </a:srgbClr>
+          </a:solidFill>
+          <a:ln w="38100">
+            <a:solidFill>
+              <a:srgbClr val="2E8B57"/>
+            </a:solidFill>
+          </a:ln>
+        </p:spPr>
+      </p:sp>
+      <p:sp>
+        <p:nvSpPr>
+          <p:cNvPr id="65" name="Answer 65"/>
+          <p:cNvSpPr/>
+          <p:nvPr/>
+        </p:nvSpPr>
+        <p:spPr>
+          <a:xfrm>
+            <a:off x="1806178" y="5255896"/>
+            <a:ext cx="996553" cy="461010"/>
+          </a:xfrm>
+          <a:prstGeom prst="roundRect">
+            <a:avLst>
+              <a:gd name="adj" fmla="val 50000"/>
+            </a:avLst>
+          </a:prstGeom>
+          <a:solidFill>
+            <a:srgbClr val="2E8B57">
+              <a:alpha val="22000"/>
+            </a:srgbClr>
+          </a:solidFill>
+          <a:ln w="38100">
+            <a:solidFill>
+              <a:srgbClr val="2E8B57"/>
+            </a:solidFill>
+          </a:ln>
+        </p:spPr>
+      </p:sp>
     </p:spTree>
   </p:cSld>
   <p:clrMapOvr>
     <a:masterClrMapping/>
   </p:clrMapOvr>
+  <p:timing>
+    <p:tnLst>
+      <p:par>
+        <p:cTn id="1" dur="indefinite" restart="never" nodeType="tmRoot">
+          <p:childTnLst>
+            <p:seq concurrent="1" nextAc="seek">
+              <p:cTn id="2" dur="indefinite" nodeType="mainSeq">
+                <p:childTnLst>
+                  <p:par>
+                    <p:cTn id="3" fill="hold">
+                      <p:stCondLst>
+                        <p:cond delay="indefinite"/>
+                      </p:stCondLst>
+                      <p:childTnLst>
+                        <p:par>
+                          <p:cTn id="4" fill="hold">
+                            <p:stCondLst>
+                              <p:cond delay="0"/>
+                            </p:stCondLst>
+                            <p:childTnLst>
+                              <p:par>
+                                <p:cTn id="5" presetID="10" presetClass="entr" presetSubtype="0" fill="hold" grpId="0" nodeType="clickEffect">
+                                  <p:stCondLst>
+                                    <p:cond delay="0"/>
+                                  </p:stCondLst>
+                                  <p:childTnLst>
+                                    <p:set>
+                                      <p:cBhvr>
+                                        <p:cTn id="6" dur="1" fill="hold">
+                                          <p:stCondLst>
+                                            <p:cond delay="0"/>
+                                          </p:stCondLst>
+                                        </p:cTn>
+                                        <p:tgtEl>
+                                          <p:spTgt spid="62"/>
+                                        </p:tgtEl>
+                                        <p:attrNameLst>
+                                          <p:attrName>style.visibility</p:attrName>
+                                        </p:attrNameLst>
+                                      </p:cBhvr>
+                                      <p:to>
+                                        <p:strVal val="visible"/>
+                                      </p:to>
+                                    </p:set>
+                                    <p:animEffect transition="in" filter="fade">
+                                      <p:cBhvr>
+                                        <p:cTn id="7" dur="500"/>
+                                        <p:tgtEl>
+                                          <p:spTgt spid="62"/>
+                                        </p:tgtEl>
+                                      </p:cBhvr>
+                                    </p:animEffect>
+                                  </p:childTnLst>
+                                </p:cTn>
+                              </p:par>
+                            </p:childTnLst>
+                          </p:cTn>
+                        </p:par>
+                      </p:childTnLst>
+                    </p:cTn>
+                  </p:par>
+                  <p:par>
+                    <p:cTn id="8" fill="hold">
+                      <p:stCondLst>
+                        <p:cond delay="indefinite"/>
+                      </p:stCondLst>
+                      <p:childTnLst>
+                        <p:par>
+                          <p:cTn id="9" fill="hold">
+                            <p:stCondLst>
+                              <p:cond delay="0"/>
+                            </p:stCondLst>
+                            <p:childTnLst>
+                              <p:par>
+                                <p:cTn id="10" presetID="10" presetClass="entr" presetSubtype="0" fill="hold" grpId="0" nodeType="clickEffect">
+                                  <p:stCondLst>
+                                    <p:cond delay="0"/>
+                                  </p:stCondLst>
+                                  <p:childTnLst>
+                                    <p:set>
+                                      <p:cBhvr>
+                                        <p:cTn id="11" dur="1" fill="hold">
+                                          <p:stCondLst>
+                                            <p:cond delay="0"/>
+                                          </p:stCondLst>
+                                        </p:cTn>
+                                        <p:tgtEl>
+                                          <p:spTgt spid="63"/>
+                                        </p:tgtEl>
+                                        <p:attrNameLst>
+                                          <p:attrName>style.visibility</p:attrName>
+                                        </p:attrNameLst>
+                                      </p:cBhvr>
+                                      <p:to>
+                                        <p:strVal val="visible"/>
+                                      </p:to>
+                                    </p:set>
+                                    <p:animEffect transition="in" filter="fade">
+                                      <p:cBhvr>
+                                        <p:cTn id="12" dur="500"/>
+                                        <p:tgtEl>
+                                          <p:spTgt spid="63"/>
+                                        </p:tgtEl>
+                                      </p:cBhvr>
+                                    </p:animEffect>
+                                  </p:childTnLst>
+                                </p:cTn>
+                              </p:par>
+                            </p:childTnLst>
+                          </p:cTn>
+                        </p:par>
+                      </p:childTnLst>
+                    </p:cTn>
+                  </p:par>
+                  <p:par>
+                    <p:cTn id="13" fill="hold">
+                      <p:stCondLst>
+                        <p:cond delay="indefinite"/>
+                      </p:stCondLst>
+                      <p:childTnLst>
+                        <p:par>
+                          <p:cTn id="14" fill="hold">
+                            <p:stCondLst>
+                              <p:cond delay="0"/>
+                            </p:stCondLst>
+                            <p:childTnLst>
+                              <p:par>
+                                <p:cTn id="15" presetID="10" presetClass="entr" presetSubtype="0" fill="hold" grpId="0" nodeType="clickEffect">
+                                  <p:stCondLst>
+                                    <p:cond delay="0"/>
+                                  </p:stCondLst>
+                                  <p:childTnLst>
+                                    <p:set>
+                                      <p:cBhvr>
+                                        <p:cTn id="16" dur="1" fill="hold">
+                                          <p:stCondLst>
+                                            <p:cond delay="0"/>
+                                          </p:stCondLst>
+                                        </p:cTn>
+                                        <p:tgtEl>
+                                          <p:spTgt spid="64"/>
+                                        </p:tgtEl>
+                                        <p:attrNameLst>
+                                          <p:attrName>style.visibility</p:attrName>
+                                        </p:attrNameLst>
+                                      </p:cBhvr>
+                                      <p:to>
+                                        <p:strVal val="visible"/>
+                                      </p:to>
+                                    </p:set>
+                                    <p:animEffect transition="in" filter="fade">
+                                      <p:cBhvr>
+                                        <p:cTn id="17" dur="500"/>
+                                        <p:tgtEl>
+                                          <p:spTgt spid="64"/>
+                                        </p:tgtEl>
+                                      </p:cBhvr>
+                                    </p:animEffect>
+                                  </p:childTnLst>
+                                </p:cTn>
+                              </p:par>
+                            </p:childTnLst>
+                          </p:cTn>
+                        </p:par>
+                      </p:childTnLst>
+                    </p:cTn>
+                  </p:par>
+                  <p:par>
+                    <p:cTn id="18" fill="hold">
+                      <p:stCondLst>
+                        <p:cond delay="indefinite"/>
+                      </p:stCondLst>
+                      <p:childTnLst>
+                        <p:par>
+                          <p:cTn id="19" fill="hold">
+                            <p:stCondLst>
+                              <p:cond delay="0"/>
+                            </p:stCondLst>
+                            <p:childTnLst>
+                              <p:par>
+                                <p:cTn id="20" presetID="10" presetClass="entr" presetSubtype="0" fill="hold" grpId="0" nodeType="clickEffect">
+                                  <p:stCondLst>
+                                    <p:cond delay="0"/>
+                                  </p:stCondLst>
+                                  <p:childTnLst>
+                                    <p:set>
+                                      <p:cBhvr>
+                                        <p:cTn id="21" dur="1" fill="hold">
+                                          <p:stCondLst>
+                                            <p:cond delay="0"/>
+                                          </p:stCondLst>
+                                        </p:cTn>
+                                        <p:tgtEl>
+                                          <p:spTgt spid="65"/>
+                                        </p:tgtEl>
+                                        <p:attrNameLst>
+                                          <p:attrName>style.visibility</p:attrName>
+                                        </p:attrNameLst>
+                                      </p:cBhvr>
+                                      <p:to>
+                                        <p:strVal val="visible"/>
+                                      </p:to>
+                                    </p:set>
+                                    <p:animEffect transition="in" filter="fade">
+                                      <p:cBhvr>
+                                        <p:cTn id="22" dur="500"/>
+                                        <p:tgtEl>
+                                          <p:spTgt spid="65"/>
+                                        </p:tgtEl>
+                                      </p:cBhvr>
+                                    </p:animEffect>
+                                  </p:childTnLst>
+                                </p:cTn>
+                              </p:par>
+                            </p:childTnLst>
+                          </p:cTn>
+                        </p:par>
+                      </p:childTnLst>
+                    </p:cTn>
+                  </p:par>
+                </p:childTnLst>
+              </p:cTn>
+              <p:prevCondLst>
+                <p:cond evt="onPrev" delay="0">
+                  <p:tgtEl>
+                    <p:sldTgt/>
+                  </p:tgtEl>
+                </p:cond>
+              </p:prevCondLst>
+              <p:nextCondLst>
+                <p:cond evt="onNext" delay="0">
+                  <p:tgtEl>
+                    <p:sldTgt/>
+                  </p:tgtEl>
+                </p:cond>
+              </p:nextCondLst>
+            </p:seq>
+          </p:childTnLst>
+        </p:cTn>
+      </p:par>
+    </p:tnLst>
+    <p:bldLst>
+      <p:bldP spid="62" grpId="0" animBg="1"/>
+      <p:bldP spid="63" grpId="0" animBg="1"/>
+      <p:bldP spid="64" grpId="0" animBg="1"/>
+      <p:bldP spid="65" grpId="0" animBg="1"/>
+    </p:bldLst>
+  </p:timing>
 </p:sld>
 </file>
 
@@ -24695,11 +25055,289 @@
           </a:p>
         </p:txBody>
       </p:sp>
+      <p:sp>
+        <p:nvSpPr>
+          <p:cNvPr id="45" name="Answer 45"/>
+          <p:cNvSpPr/>
+          <p:nvPr/>
+        </p:nvSpPr>
+        <p:spPr>
+          <a:xfrm>
+            <a:off x="1806178" y="2291717"/>
+            <a:ext cx="996553" cy="461010"/>
+          </a:xfrm>
+          <a:prstGeom prst="roundRect">
+            <a:avLst>
+              <a:gd name="adj" fmla="val 50000"/>
+            </a:avLst>
+          </a:prstGeom>
+          <a:solidFill>
+            <a:srgbClr val="2E8B57">
+              <a:alpha val="22000"/>
+            </a:srgbClr>
+          </a:solidFill>
+          <a:ln w="38100">
+            <a:solidFill>
+              <a:srgbClr val="2E8B57"/>
+            </a:solidFill>
+          </a:ln>
+        </p:spPr>
+      </p:sp>
+      <p:sp>
+        <p:nvSpPr>
+          <p:cNvPr id="46" name="Answer 46"/>
+          <p:cNvSpPr/>
+          <p:nvPr/>
+        </p:nvSpPr>
+        <p:spPr>
+          <a:xfrm>
+            <a:off x="777875" y="3279775"/>
+            <a:ext cx="928211" cy="461010"/>
+          </a:xfrm>
+          <a:prstGeom prst="roundRect">
+            <a:avLst>
+              <a:gd name="adj" fmla="val 50000"/>
+            </a:avLst>
+          </a:prstGeom>
+          <a:solidFill>
+            <a:srgbClr val="2E8B57">
+              <a:alpha val="22000"/>
+            </a:srgbClr>
+          </a:solidFill>
+          <a:ln w="38100">
+            <a:solidFill>
+              <a:srgbClr val="2E8B57"/>
+            </a:solidFill>
+          </a:ln>
+        </p:spPr>
+      </p:sp>
+      <p:sp>
+        <p:nvSpPr>
+          <p:cNvPr id="47" name="Answer 47"/>
+          <p:cNvSpPr/>
+          <p:nvPr/>
+        </p:nvSpPr>
+        <p:spPr>
+          <a:xfrm>
+            <a:off x="777875" y="4267833"/>
+            <a:ext cx="2077482" cy="461010"/>
+          </a:xfrm>
+          <a:prstGeom prst="roundRect">
+            <a:avLst>
+              <a:gd name="adj" fmla="val 50000"/>
+            </a:avLst>
+          </a:prstGeom>
+          <a:solidFill>
+            <a:srgbClr val="2E8B57">
+              <a:alpha val="22000"/>
+            </a:srgbClr>
+          </a:solidFill>
+          <a:ln w="38100">
+            <a:solidFill>
+              <a:srgbClr val="2E8B57"/>
+            </a:solidFill>
+          </a:ln>
+        </p:spPr>
+      </p:sp>
     </p:spTree>
   </p:cSld>
   <p:clrMapOvr>
     <a:masterClrMapping/>
   </p:clrMapOvr>
+  <p:timing>
+    <p:tnLst>
+      <p:par>
+        <p:cTn id="1" dur="indefinite" restart="never" nodeType="tmRoot">
+          <p:childTnLst>
+            <p:seq concurrent="1" nextAc="seek">
+              <p:cTn id="2" dur="indefinite" nodeType="mainSeq">
+                <p:childTnLst>
+                  <p:par>
+                    <p:cTn id="3" fill="hold">
+                      <p:stCondLst>
+                        <p:cond delay="indefinite"/>
+                      </p:stCondLst>
+                      <p:childTnLst>
+                        <p:par>
+                          <p:cTn id="4" fill="hold">
+                            <p:stCondLst>
+                              <p:cond delay="0"/>
+                            </p:stCondLst>
+                            <p:childTnLst>
+                              <p:par>
+                                <p:cTn id="5" presetID="10" presetClass="entr" presetSubtype="0" fill="hold" grpId="0" nodeType="clickEffect">
+                                  <p:stCondLst>
+                                    <p:cond delay="0"/>
+                                  </p:stCondLst>
+                                  <p:childTnLst>
+                                    <p:set>
+                                      <p:cBhvr>
+                                        <p:cTn id="6" dur="1" fill="hold">
+                                          <p:stCondLst>
+                                            <p:cond delay="0"/>
+                                          </p:stCondLst>
+                                        </p:cTn>
+                                        <p:tgtEl>
+                                          <p:spTgt spid="45"/>
+                                        </p:tgtEl>
+                                        <p:attrNameLst>
+                                          <p:attrName>style.visibility</p:attrName>
+                                        </p:attrNameLst>
+                                      </p:cBhvr>
+                                      <p:to>
+                                        <p:strVal val="visible"/>
+                                      </p:to>
+                                    </p:set>
+                                    <p:animEffect transition="in" filter="fade">
+                                      <p:cBhvr>
+                                        <p:cTn id="7" dur="500"/>
+                                        <p:tgtEl>
+                                          <p:spTgt spid="45"/>
+                                        </p:tgtEl>
+                                      </p:cBhvr>
+                                    </p:animEffect>
+                                  </p:childTnLst>
+                                </p:cTn>
+                              </p:par>
+                            </p:childTnLst>
+                          </p:cTn>
+                        </p:par>
+                      </p:childTnLst>
+                    </p:cTn>
+                  </p:par>
+                  <p:par>
+                    <p:cTn id="8" fill="hold">
+                      <p:stCondLst>
+                        <p:cond delay="indefinite"/>
+                      </p:stCondLst>
+                      <p:childTnLst>
+                        <p:par>
+                          <p:cTn id="9" fill="hold">
+                            <p:stCondLst>
+                              <p:cond delay="0"/>
+                            </p:stCondLst>
+                            <p:childTnLst>
+                              <p:par>
+                                <p:cTn id="10" presetID="10" presetClass="entr" presetSubtype="0" fill="hold" grpId="0" nodeType="clickEffect">
+                                  <p:stCondLst>
+                                    <p:cond delay="0"/>
+                                  </p:stCondLst>
+                                  <p:childTnLst>
+                                    <p:set>
+                                      <p:cBhvr>
+                                        <p:cTn id="11" dur="1" fill="hold">
+                                          <p:stCondLst>
+                                            <p:cond delay="0"/>
+                                          </p:stCondLst>
+                                        </p:cTn>
+                                        <p:tgtEl>
+                                          <p:spTgt spid="46"/>
+                                        </p:tgtEl>
+                                        <p:attrNameLst>
+                                          <p:attrName>style.visibility</p:attrName>
+                                        </p:attrNameLst>
+                                      </p:cBhvr>
+                                      <p:to>
+                                        <p:strVal val="visible"/>
+                                      </p:to>
+                                    </p:set>
+                                    <p:animEffect transition="in" filter="fade">
+                                      <p:cBhvr>
+                                        <p:cTn id="12" dur="500"/>
+                                        <p:tgtEl>
+                                          <p:spTgt spid="46"/>
+                                        </p:tgtEl>
+                                      </p:cBhvr>
+                                    </p:animEffect>
+                                  </p:childTnLst>
+                                </p:cTn>
+                              </p:par>
+                            </p:childTnLst>
+                          </p:cTn>
+                        </p:par>
+                      </p:childTnLst>
+                    </p:cTn>
+                  </p:par>
+                  <p:par>
+                    <p:cTn id="13" fill="hold">
+                      <p:stCondLst>
+                        <p:cond delay="indefinite"/>
+                      </p:stCondLst>
+                      <p:childTnLst>
+                        <p:par>
+                          <p:cTn id="14" fill="hold">
+                            <p:stCondLst>
+                              <p:cond delay="0"/>
+                            </p:stCondLst>
+                            <p:childTnLst>
+                              <p:par>
+                                <p:cTn id="15" presetID="10" presetClass="entr" presetSubtype="0" fill="hold" grpId="0" nodeType="clickEffect">
+                                  <p:stCondLst>
+                                    <p:cond delay="0"/>
+                                  </p:stCondLst>
+                                  <p:childTnLst>
+                                    <p:set>
+                                      <p:cBhvr>
+                                        <p:cTn id="16" dur="1" fill="hold">
+                                          <p:stCondLst>
+                                            <p:cond delay="0"/>
+                                          </p:stCondLst>
+                                        </p:cTn>
+                                        <p:tgtEl>
+                                          <p:spTgt spid="47"/>
+                                        </p:tgtEl>
+                                        <p:attrNameLst>
+                                          <p:attrName>style.visibility</p:attrName>
+                                        </p:attrNameLst>
+                                      </p:cBhvr>
+                                      <p:to>
+                                        <p:strVal val="visible"/>
+                                      </p:to>
+                                    </p:set>
+                                    <p:animEffect transition="in" filter="fade">
+                                      <p:cBhvr>
+                                        <p:cTn id="17" dur="500"/>
+                                        <p:tgtEl>
+                                          <p:spTgt spid="47"/>
+                                        </p:tgtEl>
+                                      </p:cBhvr>
+                                    </p:animEffect>
+                                  </p:childTnLst>
+                                </p:cTn>
+                              </p:par>
+                            </p:childTnLst>
+                          </p:cTn>
+                        </p:par>
+                      </p:childTnLst>
+                    </p:cTn>
+                  </p:par>
+                </p:childTnLst>
+              </p:cTn>
+              <p:prevCondLst>
+                <p:cond evt="onPrev" delay="0">
+                  <p:tgtEl>
+                    <p:sldTgt/>
+                  </p:tgtEl>
+                </p:cond>
+              </p:prevCondLst>
+              <p:nextCondLst>
+                <p:cond evt="onNext" delay="0">
+                  <p:tgtEl>
+                    <p:sldTgt/>
+                  </p:tgtEl>
+                </p:cond>
+              </p:nextCondLst>
+            </p:seq>
+          </p:childTnLst>
+        </p:cTn>
+      </p:par>
+    </p:tnLst>
+    <p:bldLst>
+      <p:bldP spid="45" grpId="0" animBg="1"/>
+      <p:bldP spid="46" grpId="0" animBg="1"/>
+      <p:bldP spid="47" grpId="0" animBg="1"/>
+    </p:bldLst>
+  </p:timing>
 </p:sld>
 </file>
 
@@ -29296,11 +29934,289 @@
           </a:p>
         </p:txBody>
       </p:sp>
+      <p:sp>
+        <p:nvSpPr>
+          <p:cNvPr id="39" name="Answer 39"/>
+          <p:cNvSpPr/>
+          <p:nvPr/>
+        </p:nvSpPr>
+        <p:spPr>
+          <a:xfrm>
+            <a:off x="2959656" y="2291717"/>
+            <a:ext cx="2467134" cy="461010"/>
+          </a:xfrm>
+          <a:prstGeom prst="roundRect">
+            <a:avLst>
+              <a:gd name="adj" fmla="val 50000"/>
+            </a:avLst>
+          </a:prstGeom>
+          <a:solidFill>
+            <a:srgbClr val="2E8B57">
+              <a:alpha val="22000"/>
+            </a:srgbClr>
+          </a:solidFill>
+          <a:ln w="38100">
+            <a:solidFill>
+              <a:srgbClr val="2E8B57"/>
+            </a:solidFill>
+          </a:ln>
+        </p:spPr>
+      </p:sp>
+      <p:sp>
+        <p:nvSpPr>
+          <p:cNvPr id="40" name="Answer 40"/>
+          <p:cNvSpPr/>
+          <p:nvPr/>
+        </p:nvSpPr>
+        <p:spPr>
+          <a:xfrm>
+            <a:off x="2510711" y="3279775"/>
+            <a:ext cx="2450068" cy="461010"/>
+          </a:xfrm>
+          <a:prstGeom prst="roundRect">
+            <a:avLst>
+              <a:gd name="adj" fmla="val 50000"/>
+            </a:avLst>
+          </a:prstGeom>
+          <a:solidFill>
+            <a:srgbClr val="2E8B57">
+              <a:alpha val="22000"/>
+            </a:srgbClr>
+          </a:solidFill>
+          <a:ln w="38100">
+            <a:solidFill>
+              <a:srgbClr val="2E8B57"/>
+            </a:solidFill>
+          </a:ln>
+        </p:spPr>
+      </p:sp>
+      <p:sp>
+        <p:nvSpPr>
+          <p:cNvPr id="41" name="Answer 41"/>
+          <p:cNvSpPr/>
+          <p:nvPr/>
+        </p:nvSpPr>
+        <p:spPr>
+          <a:xfrm>
+            <a:off x="4539615" y="4267833"/>
+            <a:ext cx="2168843" cy="461010"/>
+          </a:xfrm>
+          <a:prstGeom prst="roundRect">
+            <a:avLst>
+              <a:gd name="adj" fmla="val 50000"/>
+            </a:avLst>
+          </a:prstGeom>
+          <a:solidFill>
+            <a:srgbClr val="2E8B57">
+              <a:alpha val="22000"/>
+            </a:srgbClr>
+          </a:solidFill>
+          <a:ln w="38100">
+            <a:solidFill>
+              <a:srgbClr val="2E8B57"/>
+            </a:solidFill>
+          </a:ln>
+        </p:spPr>
+      </p:sp>
     </p:spTree>
   </p:cSld>
   <p:clrMapOvr>
     <a:masterClrMapping/>
   </p:clrMapOvr>
+  <p:timing>
+    <p:tnLst>
+      <p:par>
+        <p:cTn id="1" dur="indefinite" restart="never" nodeType="tmRoot">
+          <p:childTnLst>
+            <p:seq concurrent="1" nextAc="seek">
+              <p:cTn id="2" dur="indefinite" nodeType="mainSeq">
+                <p:childTnLst>
+                  <p:par>
+                    <p:cTn id="3" fill="hold">
+                      <p:stCondLst>
+                        <p:cond delay="indefinite"/>
+                      </p:stCondLst>
+                      <p:childTnLst>
+                        <p:par>
+                          <p:cTn id="4" fill="hold">
+                            <p:stCondLst>
+                              <p:cond delay="0"/>
+                            </p:stCondLst>
+                            <p:childTnLst>
+                              <p:par>
+                                <p:cTn id="5" presetID="10" presetClass="entr" presetSubtype="0" fill="hold" grpId="0" nodeType="clickEffect">
+                                  <p:stCondLst>
+                                    <p:cond delay="0"/>
+                                  </p:stCondLst>
+                                  <p:childTnLst>
+                                    <p:set>
+                                      <p:cBhvr>
+                                        <p:cTn id="6" dur="1" fill="hold">
+                                          <p:stCondLst>
+                                            <p:cond delay="0"/>
+                                          </p:stCondLst>
+                                        </p:cTn>
+                                        <p:tgtEl>
+                                          <p:spTgt spid="39"/>
+                                        </p:tgtEl>
+                                        <p:attrNameLst>
+                                          <p:attrName>style.visibility</p:attrName>
+                                        </p:attrNameLst>
+                                      </p:cBhvr>
+                                      <p:to>
+                                        <p:strVal val="visible"/>
+                                      </p:to>
+                                    </p:set>
+                                    <p:animEffect transition="in" filter="fade">
+                                      <p:cBhvr>
+                                        <p:cTn id="7" dur="500"/>
+                                        <p:tgtEl>
+                                          <p:spTgt spid="39"/>
+                                        </p:tgtEl>
+                                      </p:cBhvr>
+                                    </p:animEffect>
+                                  </p:childTnLst>
+                                </p:cTn>
+                              </p:par>
+                            </p:childTnLst>
+                          </p:cTn>
+                        </p:par>
+                      </p:childTnLst>
+                    </p:cTn>
+                  </p:par>
+                  <p:par>
+                    <p:cTn id="8" fill="hold">
+                      <p:stCondLst>
+                        <p:cond delay="indefinite"/>
+                      </p:stCondLst>
+                      <p:childTnLst>
+                        <p:par>
+                          <p:cTn id="9" fill="hold">
+                            <p:stCondLst>
+                              <p:cond delay="0"/>
+                            </p:stCondLst>
+                            <p:childTnLst>
+                              <p:par>
+                                <p:cTn id="10" presetID="10" presetClass="entr" presetSubtype="0" fill="hold" grpId="0" nodeType="clickEffect">
+                                  <p:stCondLst>
+                                    <p:cond delay="0"/>
+                                  </p:stCondLst>
+                                  <p:childTnLst>
+                                    <p:set>
+                                      <p:cBhvr>
+                                        <p:cTn id="11" dur="1" fill="hold">
+                                          <p:stCondLst>
+                                            <p:cond delay="0"/>
+                                          </p:stCondLst>
+                                        </p:cTn>
+                                        <p:tgtEl>
+                                          <p:spTgt spid="40"/>
+                                        </p:tgtEl>
+                                        <p:attrNameLst>
+                                          <p:attrName>style.visibility</p:attrName>
+                                        </p:attrNameLst>
+                                      </p:cBhvr>
+                                      <p:to>
+                                        <p:strVal val="visible"/>
+                                      </p:to>
+                                    </p:set>
+                                    <p:animEffect transition="in" filter="fade">
+                                      <p:cBhvr>
+                                        <p:cTn id="12" dur="500"/>
+                                        <p:tgtEl>
+                                          <p:spTgt spid="40"/>
+                                        </p:tgtEl>
+                                      </p:cBhvr>
+                                    </p:animEffect>
+                                  </p:childTnLst>
+                                </p:cTn>
+                              </p:par>
+                            </p:childTnLst>
+                          </p:cTn>
+                        </p:par>
+                      </p:childTnLst>
+                    </p:cTn>
+                  </p:par>
+                  <p:par>
+                    <p:cTn id="13" fill="hold">
+                      <p:stCondLst>
+                        <p:cond delay="indefinite"/>
+                      </p:stCondLst>
+                      <p:childTnLst>
+                        <p:par>
+                          <p:cTn id="14" fill="hold">
+                            <p:stCondLst>
+                              <p:cond delay="0"/>
+                            </p:stCondLst>
+                            <p:childTnLst>
+                              <p:par>
+                                <p:cTn id="15" presetID="10" presetClass="entr" presetSubtype="0" fill="hold" grpId="0" nodeType="clickEffect">
+                                  <p:stCondLst>
+                                    <p:cond delay="0"/>
+                                  </p:stCondLst>
+                                  <p:childTnLst>
+                                    <p:set>
+                                      <p:cBhvr>
+                                        <p:cTn id="16" dur="1" fill="hold">
+                                          <p:stCondLst>
+                                            <p:cond delay="0"/>
+                                          </p:stCondLst>
+                                        </p:cTn>
+                                        <p:tgtEl>
+                                          <p:spTgt spid="41"/>
+                                        </p:tgtEl>
+                                        <p:attrNameLst>
+                                          <p:attrName>style.visibility</p:attrName>
+                                        </p:attrNameLst>
+                                      </p:cBhvr>
+                                      <p:to>
+                                        <p:strVal val="visible"/>
+                                      </p:to>
+                                    </p:set>
+                                    <p:animEffect transition="in" filter="fade">
+                                      <p:cBhvr>
+                                        <p:cTn id="17" dur="500"/>
+                                        <p:tgtEl>
+                                          <p:spTgt spid="41"/>
+                                        </p:tgtEl>
+                                      </p:cBhvr>
+                                    </p:animEffect>
+                                  </p:childTnLst>
+                                </p:cTn>
+                              </p:par>
+                            </p:childTnLst>
+                          </p:cTn>
+                        </p:par>
+                      </p:childTnLst>
+                    </p:cTn>
+                  </p:par>
+                </p:childTnLst>
+              </p:cTn>
+              <p:prevCondLst>
+                <p:cond evt="onPrev" delay="0">
+                  <p:tgtEl>
+                    <p:sldTgt/>
+                  </p:tgtEl>
+                </p:cond>
+              </p:prevCondLst>
+              <p:nextCondLst>
+                <p:cond evt="onNext" delay="0">
+                  <p:tgtEl>
+                    <p:sldTgt/>
+                  </p:tgtEl>
+                </p:cond>
+              </p:nextCondLst>
+            </p:seq>
+          </p:childTnLst>
+        </p:cTn>
+      </p:par>
+    </p:tnLst>
+    <p:bldLst>
+      <p:bldP spid="39" grpId="0" animBg="1"/>
+      <p:bldP spid="40" grpId="0" animBg="1"/>
+      <p:bldP spid="41" grpId="0" animBg="1"/>
+    </p:bldLst>
+  </p:timing>
 </p:sld>
 </file>
 

</xml_diff>